<commit_message>
Add Gantt of Gantts slide and RAG formatting to presentation
</commit_message>
<xml_diff>
--- a/Data/Project_Portfolio_Review.pptx
+++ b/Data/Project_Portfolio_Review.pptx
@@ -15,6 +15,7 @@
     <p:sldId id="263" r:id="rId14"/>
     <p:sldId id="264" r:id="rId15"/>
     <p:sldId id="265" r:id="rId16"/>
+    <p:sldId id="266" r:id="rId17"/>
   </p:sldIdLst>
   <p:sldSz cx="12191695" cy="6858000" type="screen4x3"/>
   <p:notesSz cx="6858000" cy="9144000"/>
@@ -3105,7 +3106,7 @@
         </p:nvSpPr>
         <p:spPr>
           <a:xfrm>
-            <a:off x="685800" y="457200"/>
+            <a:off x="685800" y="1371600"/>
             <a:ext cx="10817352" cy="1371600"/>
           </a:xfrm>
           <a:prstGeom prst="rect">
@@ -3141,8 +3142,8 @@
         </p:nvSpPr>
         <p:spPr>
           <a:xfrm>
-            <a:off x="685800" y="1828800"/>
-            <a:ext cx="10817352" cy="4114800"/>
+            <a:off x="685800" y="2926080"/>
+            <a:ext cx="10817352" cy="3200400"/>
           </a:xfrm>
           <a:prstGeom prst="rect">
             <a:avLst/>
@@ -3269,6 +3270,147 @@
               </a:defRPr>
             </a:pPr>
             <a:r>
+              <a:t>8. Key Portfolio Risks &amp; RAID Log</a:t>
+            </a:r>
+          </a:p>
+        </p:txBody>
+      </p:sp>
+      <p:sp>
+        <p:nvSpPr>
+          <p:cNvPr id="3" name="TextBox 2"/>
+          <p:cNvSpPr txBox="1"/>
+          <p:nvPr/>
+        </p:nvSpPr>
+        <p:spPr>
+          <a:xfrm>
+            <a:off x="685800" y="1828800"/>
+            <a:ext cx="10817352" cy="4114800"/>
+          </a:xfrm>
+          <a:prstGeom prst="rect">
+            <a:avLst/>
+          </a:prstGeom>
+          <a:noFill/>
+        </p:spPr>
+        <p:txBody>
+          <a:bodyPr wrap="square">
+            <a:spAutoFit/>
+          </a:bodyPr>
+          <a:lstStyle/>
+          <a:p>
+            <a:pPr>
+              <a:spcAft>
+                <a:spcPts val="2000"/>
+              </a:spcAft>
+              <a:defRPr sz="3000">
+                <a:solidFill>
+                  <a:srgbClr val="555555"/>
+                </a:solidFill>
+                <a:latin typeface="Inter"/>
+              </a:defRPr>
+            </a:pPr>
+            <a:r>
+              <a:t>• Risk: Carbon sheet delivery delay from supplier</a:t>
+            </a:r>
+          </a:p>
+          <a:p>
+            <a:pPr>
+              <a:spcAft>
+                <a:spcPts val="2000"/>
+              </a:spcAft>
+              <a:defRPr sz="3000">
+                <a:solidFill>
+                  <a:srgbClr val="555555"/>
+                </a:solidFill>
+                <a:latin typeface="Inter"/>
+              </a:defRPr>
+            </a:pPr>
+            <a:r>
+              <a:t>• Issue: Welder overtime limits exceeded in fabrication</a:t>
+            </a:r>
+          </a:p>
+          <a:p>
+            <a:pPr>
+              <a:spcAft>
+                <a:spcPts val="2000"/>
+              </a:spcAft>
+              <a:defRPr sz="3000">
+                <a:solidFill>
+                  <a:srgbClr val="555555"/>
+                </a:solidFill>
+                <a:latin typeface="Inter"/>
+              </a:defRPr>
+            </a:pPr>
+            <a:r>
+              <a:t>• Dependency: Sea trials depend on DNV class approval</a:t>
+            </a:r>
+          </a:p>
+          <a:p>
+            <a:pPr>
+              <a:spcAft>
+                <a:spcPts val="2000"/>
+              </a:spcAft>
+              <a:defRPr sz="3000">
+                <a:solidFill>
+                  <a:srgbClr val="555555"/>
+                </a:solidFill>
+                <a:latin typeface="Inter"/>
+              </a:defRPr>
+            </a:pPr>
+            <a:r>
+              <a:t>• Mitigation: Allocate junior welders to assist</a:t>
+            </a:r>
+          </a:p>
+        </p:txBody>
+      </p:sp>
+    </p:spTree>
+  </p:cSld>
+  <p:clrMapOvr>
+    <a:masterClrMapping/>
+  </p:clrMapOvr>
+</p:sld>
+</file>
+
+<file path=ppt/slides/slide11.xml><?xml version="1.0" encoding="utf-8"?>
+<p:sld xmlns:a="http://schemas.openxmlformats.org/drawingml/2006/main" xmlns:p="http://schemas.openxmlformats.org/presentationml/2006/main" xmlns:r="http://schemas.openxmlformats.org/officeDocument/2006/relationships">
+  <p:cSld>
+    <p:spTree>
+      <p:nvGrpSpPr>
+        <p:cNvPr id="1" name=""/>
+        <p:cNvGrpSpPr/>
+        <p:nvPr/>
+      </p:nvGrpSpPr>
+      <p:grpSpPr/>
+      <p:sp>
+        <p:nvSpPr>
+          <p:cNvPr id="2" name="TextBox 1"/>
+          <p:cNvSpPr txBox="1"/>
+          <p:nvPr/>
+        </p:nvSpPr>
+        <p:spPr>
+          <a:xfrm>
+            <a:off x="685800" y="457200"/>
+            <a:ext cx="10817352" cy="1371600"/>
+          </a:xfrm>
+          <a:prstGeom prst="rect">
+            <a:avLst/>
+          </a:prstGeom>
+          <a:noFill/>
+        </p:spPr>
+        <p:txBody>
+          <a:bodyPr wrap="square">
+            <a:spAutoFit/>
+          </a:bodyPr>
+          <a:lstStyle/>
+          <a:p>
+            <a:pPr>
+              <a:defRPr sz="4400" b="1">
+                <a:solidFill>
+                  <a:srgbClr val="1A252F"/>
+                </a:solidFill>
+                <a:latin typeface="Outfit"/>
+              </a:defRPr>
+            </a:pPr>
+            <a:r>
               <a:t>9. Recommendations &amp; Next Steps</a:t>
             </a:r>
           </a:p>
@@ -3388,7 +3530,7 @@
         <p:spPr>
           <a:xfrm>
             <a:off x="685800" y="457200"/>
-            <a:ext cx="10817352" cy="1371600"/>
+            <a:ext cx="10817352" cy="914400"/>
           </a:xfrm>
           <a:prstGeom prst="rect">
             <a:avLst/>
@@ -3396,13 +3538,13 @@
           <a:noFill/>
         </p:spPr>
         <p:txBody>
-          <a:bodyPr wrap="square">
+          <a:bodyPr wrap="none">
             <a:spAutoFit/>
           </a:bodyPr>
           <a:lstStyle/>
           <a:p>
             <a:pPr>
-              <a:defRPr sz="4400" b="1">
+              <a:defRPr sz="4000" b="1">
                 <a:solidFill>
                   <a:srgbClr val="1A252F"/>
                 </a:solidFill>
@@ -3410,21 +3552,296 @@
               </a:defRPr>
             </a:pPr>
             <a:r>
-              <a:t>1. Portfolio Overview &amp; Health</a:t>
-            </a:r>
-          </a:p>
-        </p:txBody>
-      </p:sp>
-      <p:sp>
-        <p:nvSpPr>
-          <p:cNvPr id="3" name="TextBox 2"/>
+              <a:t>Portfolio Gantt of Gantts</a:t>
+            </a:r>
+          </a:p>
+        </p:txBody>
+      </p:sp>
+      <p:sp>
+        <p:nvSpPr>
+          <p:cNvPr id="3" name="Rectangle 2"/>
+          <p:cNvSpPr/>
+          <p:nvPr/>
+        </p:nvSpPr>
+        <p:spPr>
+          <a:xfrm>
+            <a:off x="4114800" y="1280160"/>
+            <a:ext cx="1143802" cy="274320"/>
+          </a:xfrm>
+          <a:prstGeom prst="rect">
+            <a:avLst/>
+          </a:prstGeom>
+          <a:solidFill>
+            <a:srgbClr val="F1F5F9"/>
+          </a:solidFill>
+          <a:ln>
+            <a:solidFill>
+              <a:srgbClr val="E2E8F0"/>
+            </a:solidFill>
+          </a:ln>
+        </p:spPr>
+        <p:style>
+          <a:lnRef idx="1">
+            <a:schemeClr val="accent1"/>
+          </a:lnRef>
+          <a:fillRef idx="3">
+            <a:schemeClr val="accent1"/>
+          </a:fillRef>
+          <a:effectRef idx="2">
+            <a:schemeClr val="accent1"/>
+          </a:effectRef>
+          <a:fontRef idx="minor">
+            <a:schemeClr val="lt1"/>
+          </a:fontRef>
+        </p:style>
+        <p:txBody>
+          <a:bodyPr rtlCol="0" anchor="ctr"/>
+          <a:lstStyle/>
+          <a:p>
+            <a:pPr algn="ctr">
+              <a:defRPr sz="1100" b="1">
+                <a:solidFill>
+                  <a:srgbClr val="64748B"/>
+                </a:solidFill>
+                <a:latin typeface="Inter"/>
+              </a:defRPr>
+            </a:pPr>
+            <a:r>
+              <a:t>Q4 2025</a:t>
+            </a:r>
+          </a:p>
+        </p:txBody>
+      </p:sp>
+      <p:sp>
+        <p:nvSpPr>
+          <p:cNvPr id="4" name="Rectangle 3"/>
+          <p:cNvSpPr/>
+          <p:nvPr/>
+        </p:nvSpPr>
+        <p:spPr>
+          <a:xfrm>
+            <a:off x="5258602" y="1280160"/>
+            <a:ext cx="1118936" cy="274320"/>
+          </a:xfrm>
+          <a:prstGeom prst="rect">
+            <a:avLst/>
+          </a:prstGeom>
+          <a:solidFill>
+            <a:srgbClr val="F1F5F9"/>
+          </a:solidFill>
+          <a:ln>
+            <a:solidFill>
+              <a:srgbClr val="E2E8F0"/>
+            </a:solidFill>
+          </a:ln>
+        </p:spPr>
+        <p:style>
+          <a:lnRef idx="1">
+            <a:schemeClr val="accent1"/>
+          </a:lnRef>
+          <a:fillRef idx="3">
+            <a:schemeClr val="accent1"/>
+          </a:fillRef>
+          <a:effectRef idx="2">
+            <a:schemeClr val="accent1"/>
+          </a:effectRef>
+          <a:fontRef idx="minor">
+            <a:schemeClr val="lt1"/>
+          </a:fontRef>
+        </p:style>
+        <p:txBody>
+          <a:bodyPr rtlCol="0" anchor="ctr"/>
+          <a:lstStyle/>
+          <a:p>
+            <a:pPr algn="ctr">
+              <a:defRPr sz="1100" b="1">
+                <a:solidFill>
+                  <a:srgbClr val="64748B"/>
+                </a:solidFill>
+                <a:latin typeface="Inter"/>
+              </a:defRPr>
+            </a:pPr>
+            <a:r>
+              <a:t>Q1 2026</a:t>
+            </a:r>
+          </a:p>
+        </p:txBody>
+      </p:sp>
+      <p:sp>
+        <p:nvSpPr>
+          <p:cNvPr id="5" name="Rectangle 4"/>
+          <p:cNvSpPr/>
+          <p:nvPr/>
+        </p:nvSpPr>
+        <p:spPr>
+          <a:xfrm>
+            <a:off x="6377538" y="1280160"/>
+            <a:ext cx="1131369" cy="274320"/>
+          </a:xfrm>
+          <a:prstGeom prst="rect">
+            <a:avLst/>
+          </a:prstGeom>
+          <a:solidFill>
+            <a:srgbClr val="F1F5F9"/>
+          </a:solidFill>
+          <a:ln>
+            <a:solidFill>
+              <a:srgbClr val="E2E8F0"/>
+            </a:solidFill>
+          </a:ln>
+        </p:spPr>
+        <p:style>
+          <a:lnRef idx="1">
+            <a:schemeClr val="accent1"/>
+          </a:lnRef>
+          <a:fillRef idx="3">
+            <a:schemeClr val="accent1"/>
+          </a:fillRef>
+          <a:effectRef idx="2">
+            <a:schemeClr val="accent1"/>
+          </a:effectRef>
+          <a:fontRef idx="minor">
+            <a:schemeClr val="lt1"/>
+          </a:fontRef>
+        </p:style>
+        <p:txBody>
+          <a:bodyPr rtlCol="0" anchor="ctr"/>
+          <a:lstStyle/>
+          <a:p>
+            <a:pPr algn="ctr">
+              <a:defRPr sz="1100" b="1">
+                <a:solidFill>
+                  <a:srgbClr val="64748B"/>
+                </a:solidFill>
+                <a:latin typeface="Inter"/>
+              </a:defRPr>
+            </a:pPr>
+            <a:r>
+              <a:t>Q2 2026</a:t>
+            </a:r>
+          </a:p>
+        </p:txBody>
+      </p:sp>
+      <p:sp>
+        <p:nvSpPr>
+          <p:cNvPr id="6" name="Rectangle 5"/>
+          <p:cNvSpPr/>
+          <p:nvPr/>
+        </p:nvSpPr>
+        <p:spPr>
+          <a:xfrm>
+            <a:off x="7508908" y="1280160"/>
+            <a:ext cx="1143802" cy="274320"/>
+          </a:xfrm>
+          <a:prstGeom prst="rect">
+            <a:avLst/>
+          </a:prstGeom>
+          <a:solidFill>
+            <a:srgbClr val="F1F5F9"/>
+          </a:solidFill>
+          <a:ln>
+            <a:solidFill>
+              <a:srgbClr val="E2E8F0"/>
+            </a:solidFill>
+          </a:ln>
+        </p:spPr>
+        <p:style>
+          <a:lnRef idx="1">
+            <a:schemeClr val="accent1"/>
+          </a:lnRef>
+          <a:fillRef idx="3">
+            <a:schemeClr val="accent1"/>
+          </a:fillRef>
+          <a:effectRef idx="2">
+            <a:schemeClr val="accent1"/>
+          </a:effectRef>
+          <a:fontRef idx="minor">
+            <a:schemeClr val="lt1"/>
+          </a:fontRef>
+        </p:style>
+        <p:txBody>
+          <a:bodyPr rtlCol="0" anchor="ctr"/>
+          <a:lstStyle/>
+          <a:p>
+            <a:pPr algn="ctr">
+              <a:defRPr sz="1100" b="1">
+                <a:solidFill>
+                  <a:srgbClr val="64748B"/>
+                </a:solidFill>
+                <a:latin typeface="Inter"/>
+              </a:defRPr>
+            </a:pPr>
+            <a:r>
+              <a:t>Q3 2026</a:t>
+            </a:r>
+          </a:p>
+        </p:txBody>
+      </p:sp>
+      <p:sp>
+        <p:nvSpPr>
+          <p:cNvPr id="7" name="Rectangle 6"/>
+          <p:cNvSpPr/>
+          <p:nvPr/>
+        </p:nvSpPr>
+        <p:spPr>
+          <a:xfrm>
+            <a:off x="8652710" y="1280160"/>
+            <a:ext cx="1143802" cy="274320"/>
+          </a:xfrm>
+          <a:prstGeom prst="rect">
+            <a:avLst/>
+          </a:prstGeom>
+          <a:solidFill>
+            <a:srgbClr val="F1F5F9"/>
+          </a:solidFill>
+          <a:ln>
+            <a:solidFill>
+              <a:srgbClr val="E2E8F0"/>
+            </a:solidFill>
+          </a:ln>
+        </p:spPr>
+        <p:style>
+          <a:lnRef idx="1">
+            <a:schemeClr val="accent1"/>
+          </a:lnRef>
+          <a:fillRef idx="3">
+            <a:schemeClr val="accent1"/>
+          </a:fillRef>
+          <a:effectRef idx="2">
+            <a:schemeClr val="accent1"/>
+          </a:effectRef>
+          <a:fontRef idx="minor">
+            <a:schemeClr val="lt1"/>
+          </a:fontRef>
+        </p:style>
+        <p:txBody>
+          <a:bodyPr rtlCol="0" anchor="ctr"/>
+          <a:lstStyle/>
+          <a:p>
+            <a:pPr algn="ctr">
+              <a:defRPr sz="1100" b="1">
+                <a:solidFill>
+                  <a:srgbClr val="64748B"/>
+                </a:solidFill>
+                <a:latin typeface="Inter"/>
+              </a:defRPr>
+            </a:pPr>
+            <a:r>
+              <a:t>Q4 2026</a:t>
+            </a:r>
+          </a:p>
+        </p:txBody>
+      </p:sp>
+      <p:sp>
+        <p:nvSpPr>
+          <p:cNvPr id="8" name="TextBox 7"/>
           <p:cNvSpPr txBox="1"/>
           <p:nvPr/>
         </p:nvSpPr>
         <p:spPr>
           <a:xfrm>
-            <a:off x="685800" y="1828800"/>
-            <a:ext cx="10817352" cy="4114800"/>
+            <a:off x="457200" y="1645920"/>
+            <a:ext cx="3657600" cy="457200"/>
           </a:xfrm>
           <a:prstGeom prst="rect">
             <a:avLst/>
@@ -3432,72 +3849,1148 @@
           <a:noFill/>
         </p:spPr>
         <p:txBody>
-          <a:bodyPr wrap="square">
+          <a:bodyPr wrap="none">
             <a:spAutoFit/>
           </a:bodyPr>
           <a:lstStyle/>
           <a:p>
             <a:pPr>
-              <a:spcAft>
-                <a:spcPts val="2000"/>
-              </a:spcAft>
-              <a:defRPr sz="3000">
-                <a:solidFill>
-                  <a:srgbClr val="555555"/>
+              <a:defRPr sz="1400" b="1">
+                <a:solidFill>
+                  <a:srgbClr val="1A252F"/>
+                </a:solidFill>
+                <a:latin typeface="Outfit"/>
+              </a:defRPr>
+            </a:pPr>
+            <a:r>
+              <a:t>PRJ-001: Composite Vessel</a:t>
+            </a:r>
+          </a:p>
+        </p:txBody>
+      </p:sp>
+      <p:sp>
+        <p:nvSpPr>
+          <p:cNvPr id="9" name="Rectangle 8"/>
+          <p:cNvSpPr/>
+          <p:nvPr/>
+        </p:nvSpPr>
+        <p:spPr>
+          <a:xfrm>
+            <a:off x="5258602" y="1691640"/>
+            <a:ext cx="2237873" cy="91440"/>
+          </a:xfrm>
+          <a:prstGeom prst="rect">
+            <a:avLst/>
+          </a:prstGeom>
+          <a:solidFill>
+            <a:srgbClr val="CBD5E1"/>
+          </a:solidFill>
+          <a:ln>
+            <a:noFill/>
+          </a:ln>
+        </p:spPr>
+        <p:style>
+          <a:lnRef idx="1">
+            <a:schemeClr val="accent1"/>
+          </a:lnRef>
+          <a:fillRef idx="3">
+            <a:schemeClr val="accent1"/>
+          </a:fillRef>
+          <a:effectRef idx="2">
+            <a:schemeClr val="accent1"/>
+          </a:effectRef>
+          <a:fontRef idx="minor">
+            <a:schemeClr val="lt1"/>
+          </a:fontRef>
+        </p:style>
+        <p:txBody>
+          <a:bodyPr rtlCol="0" anchor="ctr"/>
+          <a:lstStyle/>
+          <a:p>
+            <a:pPr algn="ctr"/>
+          </a:p>
+        </p:txBody>
+      </p:sp>
+      <p:sp>
+        <p:nvSpPr>
+          <p:cNvPr id="10" name="Rectangle 9"/>
+          <p:cNvSpPr/>
+          <p:nvPr/>
+        </p:nvSpPr>
+        <p:spPr>
+          <a:xfrm>
+            <a:off x="5258602" y="1828800"/>
+            <a:ext cx="2237873" cy="164592"/>
+          </a:xfrm>
+          <a:prstGeom prst="rect">
+            <a:avLst/>
+          </a:prstGeom>
+          <a:solidFill>
+            <a:srgbClr val="FEE2E2"/>
+          </a:solidFill>
+          <a:ln>
+            <a:noFill/>
+          </a:ln>
+        </p:spPr>
+        <p:style>
+          <a:lnRef idx="1">
+            <a:schemeClr val="accent1"/>
+          </a:lnRef>
+          <a:fillRef idx="3">
+            <a:schemeClr val="accent1"/>
+          </a:fillRef>
+          <a:effectRef idx="2">
+            <a:schemeClr val="accent1"/>
+          </a:effectRef>
+          <a:fontRef idx="minor">
+            <a:schemeClr val="lt1"/>
+          </a:fontRef>
+        </p:style>
+        <p:txBody>
+          <a:bodyPr rtlCol="0" anchor="ctr"/>
+          <a:lstStyle/>
+          <a:p>
+            <a:pPr algn="ctr"/>
+          </a:p>
+        </p:txBody>
+      </p:sp>
+      <p:sp>
+        <p:nvSpPr>
+          <p:cNvPr id="11" name="Rectangle 10"/>
+          <p:cNvSpPr/>
+          <p:nvPr/>
+        </p:nvSpPr>
+        <p:spPr>
+          <a:xfrm>
+            <a:off x="5258602" y="1828800"/>
+            <a:ext cx="2226684" cy="164592"/>
+          </a:xfrm>
+          <a:prstGeom prst="rect">
+            <a:avLst/>
+          </a:prstGeom>
+          <a:solidFill>
+            <a:srgbClr val="E74C3C"/>
+          </a:solidFill>
+          <a:ln>
+            <a:noFill/>
+          </a:ln>
+        </p:spPr>
+        <p:style>
+          <a:lnRef idx="1">
+            <a:schemeClr val="accent1"/>
+          </a:lnRef>
+          <a:fillRef idx="3">
+            <a:schemeClr val="accent1"/>
+          </a:fillRef>
+          <a:effectRef idx="2">
+            <a:schemeClr val="accent1"/>
+          </a:effectRef>
+          <a:fontRef idx="minor">
+            <a:schemeClr val="lt1"/>
+          </a:fontRef>
+        </p:style>
+        <p:txBody>
+          <a:bodyPr rtlCol="0" anchor="ctr"/>
+          <a:lstStyle/>
+          <a:p>
+            <a:pPr algn="ctr"/>
+          </a:p>
+        </p:txBody>
+      </p:sp>
+      <p:sp>
+        <p:nvSpPr>
+          <p:cNvPr id="12" name="TextBox 11"/>
+          <p:cNvSpPr txBox="1"/>
+          <p:nvPr/>
+        </p:nvSpPr>
+        <p:spPr>
+          <a:xfrm>
+            <a:off x="9875519" y="1737360"/>
+            <a:ext cx="1828800" cy="365760"/>
+          </a:xfrm>
+          <a:prstGeom prst="rect">
+            <a:avLst/>
+          </a:prstGeom>
+          <a:noFill/>
+        </p:spPr>
+        <p:txBody>
+          <a:bodyPr wrap="none">
+            <a:spAutoFit/>
+          </a:bodyPr>
+          <a:lstStyle/>
+          <a:p>
+            <a:pPr>
+              <a:defRPr sz="1200" b="1">
+                <a:solidFill>
+                  <a:srgbClr val="E74C3C"/>
                 </a:solidFill>
                 <a:latin typeface="Inter"/>
               </a:defRPr>
             </a:pPr>
             <a:r>
-              <a:t>• Total Baseline (BAC): 7,100,000 USD</a:t>
-            </a:r>
-          </a:p>
-          <a:p>
-            <a:pPr>
-              <a:spcAft>
-                <a:spcPts val="2000"/>
-              </a:spcAft>
-              <a:defRPr sz="3000">
-                <a:solidFill>
-                  <a:srgbClr val="555555"/>
+              <a:t>99.5% | 🔴 RED</a:t>
+            </a:r>
+          </a:p>
+        </p:txBody>
+      </p:sp>
+      <p:sp>
+        <p:nvSpPr>
+          <p:cNvPr id="13" name="TextBox 12"/>
+          <p:cNvSpPr txBox="1"/>
+          <p:nvPr/>
+        </p:nvSpPr>
+        <p:spPr>
+          <a:xfrm>
+            <a:off x="457200" y="2377440"/>
+            <a:ext cx="3657600" cy="457200"/>
+          </a:xfrm>
+          <a:prstGeom prst="rect">
+            <a:avLst/>
+          </a:prstGeom>
+          <a:noFill/>
+        </p:spPr>
+        <p:txBody>
+          <a:bodyPr wrap="none">
+            <a:spAutoFit/>
+          </a:bodyPr>
+          <a:lstStyle/>
+          <a:p>
+            <a:pPr>
+              <a:defRPr sz="1400" b="1">
+                <a:solidFill>
+                  <a:srgbClr val="1A252F"/>
+                </a:solidFill>
+                <a:latin typeface="Outfit"/>
+              </a:defRPr>
+            </a:pPr>
+            <a:r>
+              <a:t>PRJ-002: Patrol Vessel</a:t>
+            </a:r>
+          </a:p>
+        </p:txBody>
+      </p:sp>
+      <p:sp>
+        <p:nvSpPr>
+          <p:cNvPr id="14" name="Rectangle 13"/>
+          <p:cNvSpPr/>
+          <p:nvPr/>
+        </p:nvSpPr>
+        <p:spPr>
+          <a:xfrm>
+            <a:off x="7894320" y="2423160"/>
+            <a:ext cx="1889759" cy="91440"/>
+          </a:xfrm>
+          <a:prstGeom prst="rect">
+            <a:avLst/>
+          </a:prstGeom>
+          <a:solidFill>
+            <a:srgbClr val="CBD5E1"/>
+          </a:solidFill>
+          <a:ln>
+            <a:noFill/>
+          </a:ln>
+        </p:spPr>
+        <p:style>
+          <a:lnRef idx="1">
+            <a:schemeClr val="accent1"/>
+          </a:lnRef>
+          <a:fillRef idx="3">
+            <a:schemeClr val="accent1"/>
+          </a:fillRef>
+          <a:effectRef idx="2">
+            <a:schemeClr val="accent1"/>
+          </a:effectRef>
+          <a:fontRef idx="minor">
+            <a:schemeClr val="lt1"/>
+          </a:fontRef>
+        </p:style>
+        <p:txBody>
+          <a:bodyPr rtlCol="0" anchor="ctr"/>
+          <a:lstStyle/>
+          <a:p>
+            <a:pPr algn="ctr"/>
+          </a:p>
+        </p:txBody>
+      </p:sp>
+      <p:sp>
+        <p:nvSpPr>
+          <p:cNvPr id="15" name="Rectangle 14"/>
+          <p:cNvSpPr/>
+          <p:nvPr/>
+        </p:nvSpPr>
+        <p:spPr>
+          <a:xfrm>
+            <a:off x="7894320" y="2560320"/>
+            <a:ext cx="1889759" cy="164592"/>
+          </a:xfrm>
+          <a:prstGeom prst="rect">
+            <a:avLst/>
+          </a:prstGeom>
+          <a:solidFill>
+            <a:srgbClr val="DCFCE7"/>
+          </a:solidFill>
+          <a:ln>
+            <a:noFill/>
+          </a:ln>
+        </p:spPr>
+        <p:style>
+          <a:lnRef idx="1">
+            <a:schemeClr val="accent1"/>
+          </a:lnRef>
+          <a:fillRef idx="3">
+            <a:schemeClr val="accent1"/>
+          </a:fillRef>
+          <a:effectRef idx="2">
+            <a:schemeClr val="accent1"/>
+          </a:effectRef>
+          <a:fontRef idx="minor">
+            <a:schemeClr val="lt1"/>
+          </a:fontRef>
+        </p:style>
+        <p:txBody>
+          <a:bodyPr rtlCol="0" anchor="ctr"/>
+          <a:lstStyle/>
+          <a:p>
+            <a:pPr algn="ctr"/>
+          </a:p>
+        </p:txBody>
+      </p:sp>
+      <p:sp>
+        <p:nvSpPr>
+          <p:cNvPr id="16" name="TextBox 15"/>
+          <p:cNvSpPr txBox="1"/>
+          <p:nvPr/>
+        </p:nvSpPr>
+        <p:spPr>
+          <a:xfrm>
+            <a:off x="9875519" y="2468880"/>
+            <a:ext cx="1828800" cy="365760"/>
+          </a:xfrm>
+          <a:prstGeom prst="rect">
+            <a:avLst/>
+          </a:prstGeom>
+          <a:noFill/>
+        </p:spPr>
+        <p:txBody>
+          <a:bodyPr wrap="none">
+            <a:spAutoFit/>
+          </a:bodyPr>
+          <a:lstStyle/>
+          <a:p>
+            <a:pPr>
+              <a:defRPr sz="1200" b="1">
+                <a:solidFill>
+                  <a:srgbClr val="2ECC71"/>
                 </a:solidFill>
                 <a:latin typeface="Inter"/>
               </a:defRPr>
             </a:pPr>
             <a:r>
-              <a:t>• Total Spent (AC): 5,220,810 USD</a:t>
-            </a:r>
-          </a:p>
-          <a:p>
-            <a:pPr>
-              <a:spcAft>
-                <a:spcPts val="2000"/>
-              </a:spcAft>
-              <a:defRPr sz="3000">
-                <a:solidFill>
-                  <a:srgbClr val="555555"/>
+              <a:t>0.0% | 🟢 GRN</a:t>
+            </a:r>
+          </a:p>
+        </p:txBody>
+      </p:sp>
+      <p:sp>
+        <p:nvSpPr>
+          <p:cNvPr id="17" name="TextBox 16"/>
+          <p:cNvSpPr txBox="1"/>
+          <p:nvPr/>
+        </p:nvSpPr>
+        <p:spPr>
+          <a:xfrm>
+            <a:off x="457200" y="3108960"/>
+            <a:ext cx="3657600" cy="457200"/>
+          </a:xfrm>
+          <a:prstGeom prst="rect">
+            <a:avLst/>
+          </a:prstGeom>
+          <a:noFill/>
+        </p:spPr>
+        <p:txBody>
+          <a:bodyPr wrap="none">
+            <a:spAutoFit/>
+          </a:bodyPr>
+          <a:lstStyle/>
+          <a:p>
+            <a:pPr>
+              <a:defRPr sz="1400" b="1">
+                <a:solidFill>
+                  <a:srgbClr val="1A252F"/>
+                </a:solidFill>
+                <a:latin typeface="Outfit"/>
+              </a:defRPr>
+            </a:pPr>
+            <a:r>
+              <a:t>PRJ-003: Subsea Frame</a:t>
+            </a:r>
+          </a:p>
+        </p:txBody>
+      </p:sp>
+      <p:sp>
+        <p:nvSpPr>
+          <p:cNvPr id="18" name="Rectangle 17"/>
+          <p:cNvSpPr/>
+          <p:nvPr/>
+        </p:nvSpPr>
+        <p:spPr>
+          <a:xfrm>
+            <a:off x="6750517" y="3154680"/>
+            <a:ext cx="2275171" cy="91440"/>
+          </a:xfrm>
+          <a:prstGeom prst="rect">
+            <a:avLst/>
+          </a:prstGeom>
+          <a:solidFill>
+            <a:srgbClr val="CBD5E1"/>
+          </a:solidFill>
+          <a:ln>
+            <a:noFill/>
+          </a:ln>
+        </p:spPr>
+        <p:style>
+          <a:lnRef idx="1">
+            <a:schemeClr val="accent1"/>
+          </a:lnRef>
+          <a:fillRef idx="3">
+            <a:schemeClr val="accent1"/>
+          </a:fillRef>
+          <a:effectRef idx="2">
+            <a:schemeClr val="accent1"/>
+          </a:effectRef>
+          <a:fontRef idx="minor">
+            <a:schemeClr val="lt1"/>
+          </a:fontRef>
+        </p:style>
+        <p:txBody>
+          <a:bodyPr rtlCol="0" anchor="ctr"/>
+          <a:lstStyle/>
+          <a:p>
+            <a:pPr algn="ctr"/>
+          </a:p>
+        </p:txBody>
+      </p:sp>
+      <p:sp>
+        <p:nvSpPr>
+          <p:cNvPr id="19" name="Rectangle 18"/>
+          <p:cNvSpPr/>
+          <p:nvPr/>
+        </p:nvSpPr>
+        <p:spPr>
+          <a:xfrm>
+            <a:off x="6750517" y="3291840"/>
+            <a:ext cx="2275171" cy="164592"/>
+          </a:xfrm>
+          <a:prstGeom prst="rect">
+            <a:avLst/>
+          </a:prstGeom>
+          <a:solidFill>
+            <a:srgbClr val="DCFCE7"/>
+          </a:solidFill>
+          <a:ln>
+            <a:noFill/>
+          </a:ln>
+        </p:spPr>
+        <p:style>
+          <a:lnRef idx="1">
+            <a:schemeClr val="accent1"/>
+          </a:lnRef>
+          <a:fillRef idx="3">
+            <a:schemeClr val="accent1"/>
+          </a:fillRef>
+          <a:effectRef idx="2">
+            <a:schemeClr val="accent1"/>
+          </a:effectRef>
+          <a:fontRef idx="minor">
+            <a:schemeClr val="lt1"/>
+          </a:fontRef>
+        </p:style>
+        <p:txBody>
+          <a:bodyPr rtlCol="0" anchor="ctr"/>
+          <a:lstStyle/>
+          <a:p>
+            <a:pPr algn="ctr"/>
+          </a:p>
+        </p:txBody>
+      </p:sp>
+      <p:sp>
+        <p:nvSpPr>
+          <p:cNvPr id="20" name="Rectangle 19"/>
+          <p:cNvSpPr/>
+          <p:nvPr/>
+        </p:nvSpPr>
+        <p:spPr>
+          <a:xfrm>
+            <a:off x="6750517" y="3291840"/>
+            <a:ext cx="682551" cy="164592"/>
+          </a:xfrm>
+          <a:prstGeom prst="rect">
+            <a:avLst/>
+          </a:prstGeom>
+          <a:solidFill>
+            <a:srgbClr val="2ECC71"/>
+          </a:solidFill>
+          <a:ln>
+            <a:noFill/>
+          </a:ln>
+        </p:spPr>
+        <p:style>
+          <a:lnRef idx="1">
+            <a:schemeClr val="accent1"/>
+          </a:lnRef>
+          <a:fillRef idx="3">
+            <a:schemeClr val="accent1"/>
+          </a:fillRef>
+          <a:effectRef idx="2">
+            <a:schemeClr val="accent1"/>
+          </a:effectRef>
+          <a:fontRef idx="minor">
+            <a:schemeClr val="lt1"/>
+          </a:fontRef>
+        </p:style>
+        <p:txBody>
+          <a:bodyPr rtlCol="0" anchor="ctr"/>
+          <a:lstStyle/>
+          <a:p>
+            <a:pPr algn="ctr"/>
+          </a:p>
+        </p:txBody>
+      </p:sp>
+      <p:sp>
+        <p:nvSpPr>
+          <p:cNvPr id="21" name="TextBox 20"/>
+          <p:cNvSpPr txBox="1"/>
+          <p:nvPr/>
+        </p:nvSpPr>
+        <p:spPr>
+          <a:xfrm>
+            <a:off x="9875519" y="3200400"/>
+            <a:ext cx="1828800" cy="365760"/>
+          </a:xfrm>
+          <a:prstGeom prst="rect">
+            <a:avLst/>
+          </a:prstGeom>
+          <a:noFill/>
+        </p:spPr>
+        <p:txBody>
+          <a:bodyPr wrap="none">
+            <a:spAutoFit/>
+          </a:bodyPr>
+          <a:lstStyle/>
+          <a:p>
+            <a:pPr>
+              <a:defRPr sz="1200" b="1">
+                <a:solidFill>
+                  <a:srgbClr val="2ECC71"/>
                 </a:solidFill>
                 <a:latin typeface="Inter"/>
               </a:defRPr>
             </a:pPr>
             <a:r>
-              <a:t>• Earned Value (EV): 4,752,500 USD</a:t>
-            </a:r>
-          </a:p>
-          <a:p>
-            <a:pPr>
-              <a:spcAft>
-                <a:spcPts val="2000"/>
-              </a:spcAft>
-              <a:defRPr sz="3000">
-                <a:solidFill>
-                  <a:srgbClr val="555555"/>
+              <a:t>30.0% | 🟢 GRN</a:t>
+            </a:r>
+          </a:p>
+        </p:txBody>
+      </p:sp>
+      <p:sp>
+        <p:nvSpPr>
+          <p:cNvPr id="22" name="TextBox 21"/>
+          <p:cNvSpPr txBox="1"/>
+          <p:nvPr/>
+        </p:nvSpPr>
+        <p:spPr>
+          <a:xfrm>
+            <a:off x="457200" y="3840480"/>
+            <a:ext cx="3657600" cy="457200"/>
+          </a:xfrm>
+          <a:prstGeom prst="rect">
+            <a:avLst/>
+          </a:prstGeom>
+          <a:noFill/>
+        </p:spPr>
+        <p:txBody>
+          <a:bodyPr wrap="none">
+            <a:spAutoFit/>
+          </a:bodyPr>
+          <a:lstStyle/>
+          <a:p>
+            <a:pPr>
+              <a:defRPr sz="1400" b="1">
+                <a:solidFill>
+                  <a:srgbClr val="1A252F"/>
+                </a:solidFill>
+                <a:latin typeface="Outfit"/>
+              </a:defRPr>
+            </a:pPr>
+            <a:r>
+              <a:t>PRJ-004: Workboat Hull</a:t>
+            </a:r>
+          </a:p>
+        </p:txBody>
+      </p:sp>
+      <p:sp>
+        <p:nvSpPr>
+          <p:cNvPr id="23" name="Rectangle 22"/>
+          <p:cNvSpPr/>
+          <p:nvPr/>
+        </p:nvSpPr>
+        <p:spPr>
+          <a:xfrm>
+            <a:off x="5992127" y="3886200"/>
+            <a:ext cx="2275171" cy="91440"/>
+          </a:xfrm>
+          <a:prstGeom prst="rect">
+            <a:avLst/>
+          </a:prstGeom>
+          <a:solidFill>
+            <a:srgbClr val="CBD5E1"/>
+          </a:solidFill>
+          <a:ln>
+            <a:noFill/>
+          </a:ln>
+        </p:spPr>
+        <p:style>
+          <a:lnRef idx="1">
+            <a:schemeClr val="accent1"/>
+          </a:lnRef>
+          <a:fillRef idx="3">
+            <a:schemeClr val="accent1"/>
+          </a:fillRef>
+          <a:effectRef idx="2">
+            <a:schemeClr val="accent1"/>
+          </a:effectRef>
+          <a:fontRef idx="minor">
+            <a:schemeClr val="lt1"/>
+          </a:fontRef>
+        </p:style>
+        <p:txBody>
+          <a:bodyPr rtlCol="0" anchor="ctr"/>
+          <a:lstStyle/>
+          <a:p>
+            <a:pPr algn="ctr"/>
+          </a:p>
+        </p:txBody>
+      </p:sp>
+      <p:sp>
+        <p:nvSpPr>
+          <p:cNvPr id="24" name="Rectangle 23"/>
+          <p:cNvSpPr/>
+          <p:nvPr/>
+        </p:nvSpPr>
+        <p:spPr>
+          <a:xfrm>
+            <a:off x="5992127" y="4023360"/>
+            <a:ext cx="2275171" cy="164592"/>
+          </a:xfrm>
+          <a:prstGeom prst="rect">
+            <a:avLst/>
+          </a:prstGeom>
+          <a:solidFill>
+            <a:srgbClr val="DCFCE7"/>
+          </a:solidFill>
+          <a:ln>
+            <a:noFill/>
+          </a:ln>
+        </p:spPr>
+        <p:style>
+          <a:lnRef idx="1">
+            <a:schemeClr val="accent1"/>
+          </a:lnRef>
+          <a:fillRef idx="3">
+            <a:schemeClr val="accent1"/>
+          </a:fillRef>
+          <a:effectRef idx="2">
+            <a:schemeClr val="accent1"/>
+          </a:effectRef>
+          <a:fontRef idx="minor">
+            <a:schemeClr val="lt1"/>
+          </a:fontRef>
+        </p:style>
+        <p:txBody>
+          <a:bodyPr rtlCol="0" anchor="ctr"/>
+          <a:lstStyle/>
+          <a:p>
+            <a:pPr algn="ctr"/>
+          </a:p>
+        </p:txBody>
+      </p:sp>
+      <p:sp>
+        <p:nvSpPr>
+          <p:cNvPr id="25" name="Rectangle 24"/>
+          <p:cNvSpPr/>
+          <p:nvPr/>
+        </p:nvSpPr>
+        <p:spPr>
+          <a:xfrm>
+            <a:off x="5992127" y="4023360"/>
+            <a:ext cx="1592620" cy="164592"/>
+          </a:xfrm>
+          <a:prstGeom prst="rect">
+            <a:avLst/>
+          </a:prstGeom>
+          <a:solidFill>
+            <a:srgbClr val="2ECC71"/>
+          </a:solidFill>
+          <a:ln>
+            <a:noFill/>
+          </a:ln>
+        </p:spPr>
+        <p:style>
+          <a:lnRef idx="1">
+            <a:schemeClr val="accent1"/>
+          </a:lnRef>
+          <a:fillRef idx="3">
+            <a:schemeClr val="accent1"/>
+          </a:fillRef>
+          <a:effectRef idx="2">
+            <a:schemeClr val="accent1"/>
+          </a:effectRef>
+          <a:fontRef idx="minor">
+            <a:schemeClr val="lt1"/>
+          </a:fontRef>
+        </p:style>
+        <p:txBody>
+          <a:bodyPr rtlCol="0" anchor="ctr"/>
+          <a:lstStyle/>
+          <a:p>
+            <a:pPr algn="ctr"/>
+          </a:p>
+        </p:txBody>
+      </p:sp>
+      <p:sp>
+        <p:nvSpPr>
+          <p:cNvPr id="26" name="TextBox 25"/>
+          <p:cNvSpPr txBox="1"/>
+          <p:nvPr/>
+        </p:nvSpPr>
+        <p:spPr>
+          <a:xfrm>
+            <a:off x="9875519" y="3931920"/>
+            <a:ext cx="1828800" cy="365760"/>
+          </a:xfrm>
+          <a:prstGeom prst="rect">
+            <a:avLst/>
+          </a:prstGeom>
+          <a:noFill/>
+        </p:spPr>
+        <p:txBody>
+          <a:bodyPr wrap="none">
+            <a:spAutoFit/>
+          </a:bodyPr>
+          <a:lstStyle/>
+          <a:p>
+            <a:pPr>
+              <a:defRPr sz="1200" b="1">
+                <a:solidFill>
+                  <a:srgbClr val="2ECC71"/>
                 </a:solidFill>
                 <a:latin typeface="Inter"/>
               </a:defRPr>
             </a:pPr>
             <a:r>
-              <a:t>• Portfolio CPI: 0.91 (Muted cost overrun)</a:t>
+              <a:t>70.0% | 🟢 GRN</a:t>
+            </a:r>
+          </a:p>
+        </p:txBody>
+      </p:sp>
+      <p:sp>
+        <p:nvSpPr>
+          <p:cNvPr id="27" name="TextBox 26"/>
+          <p:cNvSpPr txBox="1"/>
+          <p:nvPr/>
+        </p:nvSpPr>
+        <p:spPr>
+          <a:xfrm>
+            <a:off x="457200" y="4572000"/>
+            <a:ext cx="3657600" cy="457200"/>
+          </a:xfrm>
+          <a:prstGeom prst="rect">
+            <a:avLst/>
+          </a:prstGeom>
+          <a:noFill/>
+        </p:spPr>
+        <p:txBody>
+          <a:bodyPr wrap="none">
+            <a:spAutoFit/>
+          </a:bodyPr>
+          <a:lstStyle/>
+          <a:p>
+            <a:pPr>
+              <a:defRPr sz="1400" b="1">
+                <a:solidFill>
+                  <a:srgbClr val="1A252F"/>
+                </a:solidFill>
+                <a:latin typeface="Outfit"/>
+              </a:defRPr>
+            </a:pPr>
+            <a:r>
+              <a:t>PRJ-005: Logistics Pontoon</a:t>
+            </a:r>
+          </a:p>
+        </p:txBody>
+      </p:sp>
+      <p:sp>
+        <p:nvSpPr>
+          <p:cNvPr id="28" name="Rectangle 27"/>
+          <p:cNvSpPr/>
+          <p:nvPr/>
+        </p:nvSpPr>
+        <p:spPr>
+          <a:xfrm>
+            <a:off x="5644013" y="4617720"/>
+            <a:ext cx="2237873" cy="91440"/>
+          </a:xfrm>
+          <a:prstGeom prst="rect">
+            <a:avLst/>
+          </a:prstGeom>
+          <a:solidFill>
+            <a:srgbClr val="CBD5E1"/>
+          </a:solidFill>
+          <a:ln>
+            <a:noFill/>
+          </a:ln>
+        </p:spPr>
+        <p:style>
+          <a:lnRef idx="1">
+            <a:schemeClr val="accent1"/>
+          </a:lnRef>
+          <a:fillRef idx="3">
+            <a:schemeClr val="accent1"/>
+          </a:fillRef>
+          <a:effectRef idx="2">
+            <a:schemeClr val="accent1"/>
+          </a:effectRef>
+          <a:fontRef idx="minor">
+            <a:schemeClr val="lt1"/>
+          </a:fontRef>
+        </p:style>
+        <p:txBody>
+          <a:bodyPr rtlCol="0" anchor="ctr"/>
+          <a:lstStyle/>
+          <a:p>
+            <a:pPr algn="ctr"/>
+          </a:p>
+        </p:txBody>
+      </p:sp>
+      <p:sp>
+        <p:nvSpPr>
+          <p:cNvPr id="29" name="Rectangle 28"/>
+          <p:cNvSpPr/>
+          <p:nvPr/>
+        </p:nvSpPr>
+        <p:spPr>
+          <a:xfrm>
+            <a:off x="5644013" y="4754880"/>
+            <a:ext cx="2237873" cy="164592"/>
+          </a:xfrm>
+          <a:prstGeom prst="rect">
+            <a:avLst/>
+          </a:prstGeom>
+          <a:solidFill>
+            <a:srgbClr val="DCFCE7"/>
+          </a:solidFill>
+          <a:ln>
+            <a:noFill/>
+          </a:ln>
+        </p:spPr>
+        <p:style>
+          <a:lnRef idx="1">
+            <a:schemeClr val="accent1"/>
+          </a:lnRef>
+          <a:fillRef idx="3">
+            <a:schemeClr val="accent1"/>
+          </a:fillRef>
+          <a:effectRef idx="2">
+            <a:schemeClr val="accent1"/>
+          </a:effectRef>
+          <a:fontRef idx="minor">
+            <a:schemeClr val="lt1"/>
+          </a:fontRef>
+        </p:style>
+        <p:txBody>
+          <a:bodyPr rtlCol="0" anchor="ctr"/>
+          <a:lstStyle/>
+          <a:p>
+            <a:pPr algn="ctr"/>
+          </a:p>
+        </p:txBody>
+      </p:sp>
+      <p:sp>
+        <p:nvSpPr>
+          <p:cNvPr id="30" name="Rectangle 29"/>
+          <p:cNvSpPr/>
+          <p:nvPr/>
+        </p:nvSpPr>
+        <p:spPr>
+          <a:xfrm>
+            <a:off x="5644013" y="4754880"/>
+            <a:ext cx="2014086" cy="164592"/>
+          </a:xfrm>
+          <a:prstGeom prst="rect">
+            <a:avLst/>
+          </a:prstGeom>
+          <a:solidFill>
+            <a:srgbClr val="2ECC71"/>
+          </a:solidFill>
+          <a:ln>
+            <a:noFill/>
+          </a:ln>
+        </p:spPr>
+        <p:style>
+          <a:lnRef idx="1">
+            <a:schemeClr val="accent1"/>
+          </a:lnRef>
+          <a:fillRef idx="3">
+            <a:schemeClr val="accent1"/>
+          </a:fillRef>
+          <a:effectRef idx="2">
+            <a:schemeClr val="accent1"/>
+          </a:effectRef>
+          <a:fontRef idx="minor">
+            <a:schemeClr val="lt1"/>
+          </a:fontRef>
+        </p:style>
+        <p:txBody>
+          <a:bodyPr rtlCol="0" anchor="ctr"/>
+          <a:lstStyle/>
+          <a:p>
+            <a:pPr algn="ctr"/>
+          </a:p>
+        </p:txBody>
+      </p:sp>
+      <p:sp>
+        <p:nvSpPr>
+          <p:cNvPr id="31" name="TextBox 30"/>
+          <p:cNvSpPr txBox="1"/>
+          <p:nvPr/>
+        </p:nvSpPr>
+        <p:spPr>
+          <a:xfrm>
+            <a:off x="9875519" y="4663440"/>
+            <a:ext cx="1828800" cy="365760"/>
+          </a:xfrm>
+          <a:prstGeom prst="rect">
+            <a:avLst/>
+          </a:prstGeom>
+          <a:noFill/>
+        </p:spPr>
+        <p:txBody>
+          <a:bodyPr wrap="none">
+            <a:spAutoFit/>
+          </a:bodyPr>
+          <a:lstStyle/>
+          <a:p>
+            <a:pPr>
+              <a:defRPr sz="1200" b="1">
+                <a:solidFill>
+                  <a:srgbClr val="2ECC71"/>
+                </a:solidFill>
+                <a:latin typeface="Inter"/>
+              </a:defRPr>
+            </a:pPr>
+            <a:r>
+              <a:t>90.0% | 🟢 GRN</a:t>
+            </a:r>
+          </a:p>
+        </p:txBody>
+      </p:sp>
+      <p:sp>
+        <p:nvSpPr>
+          <p:cNvPr id="32" name="TextBox 31"/>
+          <p:cNvSpPr txBox="1"/>
+          <p:nvPr/>
+        </p:nvSpPr>
+        <p:spPr>
+          <a:xfrm>
+            <a:off x="457200" y="5303520"/>
+            <a:ext cx="3657600" cy="457200"/>
+          </a:xfrm>
+          <a:prstGeom prst="rect">
+            <a:avLst/>
+          </a:prstGeom>
+          <a:noFill/>
+        </p:spPr>
+        <p:txBody>
+          <a:bodyPr wrap="none">
+            <a:spAutoFit/>
+          </a:bodyPr>
+          <a:lstStyle/>
+          <a:p>
+            <a:pPr>
+              <a:defRPr sz="1400" b="1">
+                <a:solidFill>
+                  <a:srgbClr val="1A252F"/>
+                </a:solidFill>
+                <a:latin typeface="Outfit"/>
+              </a:defRPr>
+            </a:pPr>
+            <a:r>
+              <a:t>PRJ-006: Cargo Hatch</a:t>
+            </a:r>
+          </a:p>
+        </p:txBody>
+      </p:sp>
+      <p:sp>
+        <p:nvSpPr>
+          <p:cNvPr id="33" name="Rectangle 32"/>
+          <p:cNvSpPr/>
+          <p:nvPr/>
+        </p:nvSpPr>
+        <p:spPr>
+          <a:xfrm>
+            <a:off x="4114800" y="5349240"/>
+            <a:ext cx="2250306" cy="91440"/>
+          </a:xfrm>
+          <a:prstGeom prst="rect">
+            <a:avLst/>
+          </a:prstGeom>
+          <a:solidFill>
+            <a:srgbClr val="CBD5E1"/>
+          </a:solidFill>
+          <a:ln>
+            <a:noFill/>
+          </a:ln>
+        </p:spPr>
+        <p:style>
+          <a:lnRef idx="1">
+            <a:schemeClr val="accent1"/>
+          </a:lnRef>
+          <a:fillRef idx="3">
+            <a:schemeClr val="accent1"/>
+          </a:fillRef>
+          <a:effectRef idx="2">
+            <a:schemeClr val="accent1"/>
+          </a:effectRef>
+          <a:fontRef idx="minor">
+            <a:schemeClr val="lt1"/>
+          </a:fontRef>
+        </p:style>
+        <p:txBody>
+          <a:bodyPr rtlCol="0" anchor="ctr"/>
+          <a:lstStyle/>
+          <a:p>
+            <a:pPr algn="ctr"/>
+          </a:p>
+        </p:txBody>
+      </p:sp>
+      <p:sp>
+        <p:nvSpPr>
+          <p:cNvPr id="34" name="Rectangle 33"/>
+          <p:cNvSpPr/>
+          <p:nvPr/>
+        </p:nvSpPr>
+        <p:spPr>
+          <a:xfrm>
+            <a:off x="4114800" y="5486400"/>
+            <a:ext cx="2250306" cy="164592"/>
+          </a:xfrm>
+          <a:prstGeom prst="rect">
+            <a:avLst/>
+          </a:prstGeom>
+          <a:solidFill>
+            <a:srgbClr val="DCFCE7"/>
+          </a:solidFill>
+          <a:ln>
+            <a:noFill/>
+          </a:ln>
+        </p:spPr>
+        <p:style>
+          <a:lnRef idx="1">
+            <a:schemeClr val="accent1"/>
+          </a:lnRef>
+          <a:fillRef idx="3">
+            <a:schemeClr val="accent1"/>
+          </a:fillRef>
+          <a:effectRef idx="2">
+            <a:schemeClr val="accent1"/>
+          </a:effectRef>
+          <a:fontRef idx="minor">
+            <a:schemeClr val="lt1"/>
+          </a:fontRef>
+        </p:style>
+        <p:txBody>
+          <a:bodyPr rtlCol="0" anchor="ctr"/>
+          <a:lstStyle/>
+          <a:p>
+            <a:pPr algn="ctr"/>
+          </a:p>
+        </p:txBody>
+      </p:sp>
+      <p:sp>
+        <p:nvSpPr>
+          <p:cNvPr id="35" name="Rectangle 34"/>
+          <p:cNvSpPr/>
+          <p:nvPr/>
+        </p:nvSpPr>
+        <p:spPr>
+          <a:xfrm>
+            <a:off x="4114800" y="5486400"/>
+            <a:ext cx="2250306" cy="164592"/>
+          </a:xfrm>
+          <a:prstGeom prst="rect">
+            <a:avLst/>
+          </a:prstGeom>
+          <a:solidFill>
+            <a:srgbClr val="2ECC71"/>
+          </a:solidFill>
+          <a:ln>
+            <a:noFill/>
+          </a:ln>
+        </p:spPr>
+        <p:style>
+          <a:lnRef idx="1">
+            <a:schemeClr val="accent1"/>
+          </a:lnRef>
+          <a:fillRef idx="3">
+            <a:schemeClr val="accent1"/>
+          </a:fillRef>
+          <a:effectRef idx="2">
+            <a:schemeClr val="accent1"/>
+          </a:effectRef>
+          <a:fontRef idx="minor">
+            <a:schemeClr val="lt1"/>
+          </a:fontRef>
+        </p:style>
+        <p:txBody>
+          <a:bodyPr rtlCol="0" anchor="ctr"/>
+          <a:lstStyle/>
+          <a:p>
+            <a:pPr algn="ctr"/>
+          </a:p>
+        </p:txBody>
+      </p:sp>
+      <p:sp>
+        <p:nvSpPr>
+          <p:cNvPr id="36" name="TextBox 35"/>
+          <p:cNvSpPr txBox="1"/>
+          <p:nvPr/>
+        </p:nvSpPr>
+        <p:spPr>
+          <a:xfrm>
+            <a:off x="9875519" y="5394959"/>
+            <a:ext cx="1828800" cy="365760"/>
+          </a:xfrm>
+          <a:prstGeom prst="rect">
+            <a:avLst/>
+          </a:prstGeom>
+          <a:noFill/>
+        </p:spPr>
+        <p:txBody>
+          <a:bodyPr wrap="none">
+            <a:spAutoFit/>
+          </a:bodyPr>
+          <a:lstStyle/>
+          <a:p>
+            <a:pPr>
+              <a:defRPr sz="1200" b="1">
+                <a:solidFill>
+                  <a:srgbClr val="2ECC71"/>
+                </a:solidFill>
+                <a:latin typeface="Inter"/>
+              </a:defRPr>
+            </a:pPr>
+            <a:r>
+              <a:t>100.0% | 🟢 GRN</a:t>
             </a:r>
           </a:p>
         </p:txBody>
@@ -3551,7 +5044,7 @@
               </a:defRPr>
             </a:pPr>
             <a:r>
-              <a:t>2. PRJ-001 Vessel Construction</a:t>
+              <a:t>1. Portfolio Overview &amp; Health</a:t>
             </a:r>
           </a:p>
         </p:txBody>
@@ -3590,7 +5083,7 @@
               </a:defRPr>
             </a:pPr>
             <a:r>
-              <a:t>• Status: Completed (99.5% progress)</a:t>
+              <a:t>• Total Baseline (BAC): 7,100,000 USD</a:t>
             </a:r>
           </a:p>
           <a:p>
@@ -3606,7 +5099,7 @@
               </a:defRPr>
             </a:pPr>
             <a:r>
-              <a:t>• Baseline: 1.5M USD | Actual Cost: 1.85M USD</a:t>
+              <a:t>• Total Spent (AC): 5,220,810 USD</a:t>
             </a:r>
           </a:p>
           <a:p>
@@ -3622,7 +5115,7 @@
               </a:defRPr>
             </a:pPr>
             <a:r>
-              <a:t>• CPI: 0.81 | Total Overrun: -356K USD</a:t>
+              <a:t>• Earned Value (EV): 4,752,500 USD</a:t>
             </a:r>
           </a:p>
           <a:p>
@@ -3638,7 +5131,7 @@
               </a:defRPr>
             </a:pPr>
             <a:r>
-              <a:t>• Action: Renegotiate contractor rates &amp; freeze VOs</a:t>
+              <a:t>• Portfolio CPI: 0.91 (Muted cost overrun)</a:t>
             </a:r>
           </a:p>
         </p:txBody>
@@ -3692,7 +5185,7 @@
               </a:defRPr>
             </a:pPr>
             <a:r>
-              <a:t>3. PRJ-002 Patrol Vessel Design</a:t>
+              <a:t>2. PRJ-001 Vessel Construction</a:t>
             </a:r>
           </a:p>
         </p:txBody>
@@ -3705,8 +5198,8 @@
         </p:nvSpPr>
         <p:spPr>
           <a:xfrm>
-            <a:off x="685800" y="1828800"/>
-            <a:ext cx="10817352" cy="4114800"/>
+            <a:off x="8686800" y="594360"/>
+            <a:ext cx="2743200" cy="731520"/>
           </a:xfrm>
           <a:prstGeom prst="rect">
             <a:avLst/>
@@ -3714,6 +5207,42 @@
           <a:noFill/>
         </p:spPr>
         <p:txBody>
+          <a:bodyPr wrap="none">
+            <a:spAutoFit/>
+          </a:bodyPr>
+          <a:lstStyle/>
+          <a:p>
+            <a:pPr>
+              <a:defRPr sz="2000" b="1">
+                <a:solidFill>
+                  <a:srgbClr val="E74C3C"/>
+                </a:solidFill>
+                <a:latin typeface="Inter"/>
+              </a:defRPr>
+            </a:pPr>
+            <a:r>
+              <a:t>🔴 CRITICAL</a:t>
+            </a:r>
+          </a:p>
+        </p:txBody>
+      </p:sp>
+      <p:sp>
+        <p:nvSpPr>
+          <p:cNvPr id="4" name="TextBox 3"/>
+          <p:cNvSpPr txBox="1"/>
+          <p:nvPr/>
+        </p:nvSpPr>
+        <p:spPr>
+          <a:xfrm>
+            <a:off x="685800" y="1828800"/>
+            <a:ext cx="10817352" cy="4114800"/>
+          </a:xfrm>
+          <a:prstGeom prst="rect">
+            <a:avLst/>
+          </a:prstGeom>
+          <a:noFill/>
+        </p:spPr>
+        <p:txBody>
           <a:bodyPr wrap="square">
             <a:spAutoFit/>
           </a:bodyPr>
@@ -3725,13 +5254,13 @@
               </a:spcAft>
               <a:defRPr sz="3000">
                 <a:solidFill>
-                  <a:srgbClr val="555555"/>
+                  <a:srgbClr val="E74C3C"/>
                 </a:solidFill>
                 <a:latin typeface="Inter"/>
               </a:defRPr>
             </a:pPr>
             <a:r>
-              <a:t>• Status: Planned (0% progress)</a:t>
+              <a:t>• Status: Completed (99.5% progress) | 🔴 RED</a:t>
             </a:r>
           </a:p>
           <a:p>
@@ -3747,7 +5276,7 @@
               </a:defRPr>
             </a:pPr>
             <a:r>
-              <a:t>• Baseline Budget: 800,000 USD</a:t>
+              <a:t>• Baseline: 1.5M USD | Actual Cost: 1.85M USD</a:t>
             </a:r>
           </a:p>
           <a:p>
@@ -3763,7 +5292,7 @@
               </a:defRPr>
             </a:pPr>
             <a:r>
-              <a:t>• Planned Start: Aug 2026 | Finish: Dec 2026</a:t>
+              <a:t>• CPI: 0.81 | Total Overrun: -356K USD</a:t>
             </a:r>
           </a:p>
           <a:p>
@@ -3779,7 +5308,7 @@
               </a:defRPr>
             </a:pPr>
             <a:r>
-              <a:t>• Focus: Carbon mold design and CFD analysis</a:t>
+              <a:t>• Action: Renegotiate contractor rates &amp; freeze VOs</a:t>
             </a:r>
           </a:p>
         </p:txBody>
@@ -3833,7 +5362,7 @@
               </a:defRPr>
             </a:pPr>
             <a:r>
-              <a:t>4. PRJ-003 Subsea Cable Frame</a:t>
+              <a:t>3. PRJ-002 Patrol Vessel Design</a:t>
             </a:r>
           </a:p>
         </p:txBody>
@@ -3846,8 +5375,8 @@
         </p:nvSpPr>
         <p:spPr>
           <a:xfrm>
-            <a:off x="685800" y="1828800"/>
-            <a:ext cx="10817352" cy="4114800"/>
+            <a:off x="8686800" y="594360"/>
+            <a:ext cx="2743200" cy="731520"/>
           </a:xfrm>
           <a:prstGeom prst="rect">
             <a:avLst/>
@@ -3855,6 +5384,42 @@
           <a:noFill/>
         </p:spPr>
         <p:txBody>
+          <a:bodyPr wrap="none">
+            <a:spAutoFit/>
+          </a:bodyPr>
+          <a:lstStyle/>
+          <a:p>
+            <a:pPr>
+              <a:defRPr sz="2000" b="1">
+                <a:solidFill>
+                  <a:srgbClr val="2ECC71"/>
+                </a:solidFill>
+                <a:latin typeface="Inter"/>
+              </a:defRPr>
+            </a:pPr>
+            <a:r>
+              <a:t>🟢 ON TRACK</a:t>
+            </a:r>
+          </a:p>
+        </p:txBody>
+      </p:sp>
+      <p:sp>
+        <p:nvSpPr>
+          <p:cNvPr id="4" name="TextBox 3"/>
+          <p:cNvSpPr txBox="1"/>
+          <p:nvPr/>
+        </p:nvSpPr>
+        <p:spPr>
+          <a:xfrm>
+            <a:off x="685800" y="1828800"/>
+            <a:ext cx="10817352" cy="4114800"/>
+          </a:xfrm>
+          <a:prstGeom prst="rect">
+            <a:avLst/>
+          </a:prstGeom>
+          <a:noFill/>
+        </p:spPr>
+        <p:txBody>
           <a:bodyPr wrap="square">
             <a:spAutoFit/>
           </a:bodyPr>
@@ -3866,13 +5431,13 @@
               </a:spcAft>
               <a:defRPr sz="3000">
                 <a:solidFill>
-                  <a:srgbClr val="555555"/>
+                  <a:srgbClr val="2ECC71"/>
                 </a:solidFill>
                 <a:latin typeface="Inter"/>
               </a:defRPr>
             </a:pPr>
             <a:r>
-              <a:t>• Status: Active (30% progress)</a:t>
+              <a:t>• Status: Planned (0% progress) | 🟢 GREEN</a:t>
             </a:r>
           </a:p>
           <a:p>
@@ -3888,7 +5453,7 @@
               </a:defRPr>
             </a:pPr>
             <a:r>
-              <a:t>• Baseline: 1.2M USD | Spent: 382.5K USD</a:t>
+              <a:t>• Baseline Budget: 800,000 USD</a:t>
             </a:r>
           </a:p>
           <a:p>
@@ -3904,7 +5469,7 @@
               </a:defRPr>
             </a:pPr>
             <a:r>
-              <a:t>• CPI: 0.94 (Tracking close to budget)</a:t>
+              <a:t>• Planned Start: Aug 2026 | Finish: Dec 2026</a:t>
             </a:r>
           </a:p>
           <a:p>
@@ -3920,7 +5485,7 @@
               </a:defRPr>
             </a:pPr>
             <a:r>
-              <a:t>• Focus: Engineering complete, steel fabrication starting</a:t>
+              <a:t>• Focus: Carbon mold design and CFD analysis</a:t>
             </a:r>
           </a:p>
         </p:txBody>
@@ -3974,7 +5539,7 @@
               </a:defRPr>
             </a:pPr>
             <a:r>
-              <a:t>5. PRJ-004 Workboat Hull</a:t>
+              <a:t>4. PRJ-003 Subsea Frame</a:t>
             </a:r>
           </a:p>
         </p:txBody>
@@ -3987,8 +5552,8 @@
         </p:nvSpPr>
         <p:spPr>
           <a:xfrm>
-            <a:off x="685800" y="1828800"/>
-            <a:ext cx="10817352" cy="4114800"/>
+            <a:off x="8686800" y="594360"/>
+            <a:ext cx="2743200" cy="731520"/>
           </a:xfrm>
           <a:prstGeom prst="rect">
             <a:avLst/>
@@ -3996,6 +5561,42 @@
           <a:noFill/>
         </p:spPr>
         <p:txBody>
+          <a:bodyPr wrap="none">
+            <a:spAutoFit/>
+          </a:bodyPr>
+          <a:lstStyle/>
+          <a:p>
+            <a:pPr>
+              <a:defRPr sz="2000" b="1">
+                <a:solidFill>
+                  <a:srgbClr val="2ECC71"/>
+                </a:solidFill>
+                <a:latin typeface="Inter"/>
+              </a:defRPr>
+            </a:pPr>
+            <a:r>
+              <a:t>🟢 ON TRACK</a:t>
+            </a:r>
+          </a:p>
+        </p:txBody>
+      </p:sp>
+      <p:sp>
+        <p:nvSpPr>
+          <p:cNvPr id="4" name="TextBox 3"/>
+          <p:cNvSpPr txBox="1"/>
+          <p:nvPr/>
+        </p:nvSpPr>
+        <p:spPr>
+          <a:xfrm>
+            <a:off x="685800" y="1828800"/>
+            <a:ext cx="10817352" cy="4114800"/>
+          </a:xfrm>
+          <a:prstGeom prst="rect">
+            <a:avLst/>
+          </a:prstGeom>
+          <a:noFill/>
+        </p:spPr>
+        <p:txBody>
           <a:bodyPr wrap="square">
             <a:spAutoFit/>
           </a:bodyPr>
@@ -4007,13 +5608,13 @@
               </a:spcAft>
               <a:defRPr sz="3000">
                 <a:solidFill>
-                  <a:srgbClr val="555555"/>
+                  <a:srgbClr val="2ECC71"/>
                 </a:solidFill>
                 <a:latin typeface="Inter"/>
               </a:defRPr>
             </a:pPr>
             <a:r>
-              <a:t>• Status: Active (70% progress)</a:t>
+              <a:t>• Status: Active (30% progress) | 🟢 GREEN</a:t>
             </a:r>
           </a:p>
           <a:p>
@@ -4029,7 +5630,7 @@
               </a:defRPr>
             </a:pPr>
             <a:r>
-              <a:t>• Baseline: 2.0M USD | Spent: 1.48M USD</a:t>
+              <a:t>• Baseline: 1.2M USD | Spent: 382.5K USD</a:t>
             </a:r>
           </a:p>
           <a:p>
@@ -4045,7 +5646,7 @@
               </a:defRPr>
             </a:pPr>
             <a:r>
-              <a:t>• CPI: 0.95 (Slight budget pressure)</a:t>
+              <a:t>• CPI: 0.94 (Tracking close to budget)</a:t>
             </a:r>
           </a:p>
           <a:p>
@@ -4061,7 +5662,7 @@
               </a:defRPr>
             </a:pPr>
             <a:r>
-              <a:t>• Focus: Drawings approved, welding &amp; assembly ongoing</a:t>
+              <a:t>• Focus: Engineering complete, steel fabrication starting</a:t>
             </a:r>
           </a:p>
         </p:txBody>
@@ -4115,7 +5716,7 @@
               </a:defRPr>
             </a:pPr>
             <a:r>
-              <a:t>6. PRJ-005 Logistics Pontoon</a:t>
+              <a:t>5. PRJ-004 Workboat Hull</a:t>
             </a:r>
           </a:p>
         </p:txBody>
@@ -4128,8 +5729,8 @@
         </p:nvSpPr>
         <p:spPr>
           <a:xfrm>
-            <a:off x="685800" y="1828800"/>
-            <a:ext cx="10817352" cy="4114800"/>
+            <a:off x="8686800" y="594360"/>
+            <a:ext cx="2743200" cy="731520"/>
           </a:xfrm>
           <a:prstGeom prst="rect">
             <a:avLst/>
@@ -4137,6 +5738,42 @@
           <a:noFill/>
         </p:spPr>
         <p:txBody>
+          <a:bodyPr wrap="none">
+            <a:spAutoFit/>
+          </a:bodyPr>
+          <a:lstStyle/>
+          <a:p>
+            <a:pPr>
+              <a:defRPr sz="2000" b="1">
+                <a:solidFill>
+                  <a:srgbClr val="2ECC71"/>
+                </a:solidFill>
+                <a:latin typeface="Inter"/>
+              </a:defRPr>
+            </a:pPr>
+            <a:r>
+              <a:t>🟢 ON TRACK</a:t>
+            </a:r>
+          </a:p>
+        </p:txBody>
+      </p:sp>
+      <p:sp>
+        <p:nvSpPr>
+          <p:cNvPr id="4" name="TextBox 3"/>
+          <p:cNvSpPr txBox="1"/>
+          <p:nvPr/>
+        </p:nvSpPr>
+        <p:spPr>
+          <a:xfrm>
+            <a:off x="685800" y="1828800"/>
+            <a:ext cx="10817352" cy="4114800"/>
+          </a:xfrm>
+          <a:prstGeom prst="rect">
+            <a:avLst/>
+          </a:prstGeom>
+          <a:noFill/>
+        </p:spPr>
+        <p:txBody>
           <a:bodyPr wrap="square">
             <a:spAutoFit/>
           </a:bodyPr>
@@ -4148,13 +5785,13 @@
               </a:spcAft>
               <a:defRPr sz="3000">
                 <a:solidFill>
-                  <a:srgbClr val="555555"/>
+                  <a:srgbClr val="2ECC71"/>
                 </a:solidFill>
                 <a:latin typeface="Inter"/>
               </a:defRPr>
             </a:pPr>
             <a:r>
-              <a:t>• Status: Active (90% progress)</a:t>
+              <a:t>• Status: Active (70% progress) | 🟢 GREEN</a:t>
             </a:r>
           </a:p>
           <a:p>
@@ -4170,7 +5807,7 @@
               </a:defRPr>
             </a:pPr>
             <a:r>
-              <a:t>• Baseline: 1.0M USD | Spent: 927K USD</a:t>
+              <a:t>• Baseline: 2.0M USD | Spent: 1.48M USD</a:t>
             </a:r>
           </a:p>
           <a:p>
@@ -4186,7 +5823,7 @@
               </a:defRPr>
             </a:pPr>
             <a:r>
-              <a:t>• CPI: 0.97 (In good financial standing)</a:t>
+              <a:t>• CPI: 0.95 (Slight budget pressure)</a:t>
             </a:r>
           </a:p>
           <a:p>
@@ -4202,7 +5839,7 @@
               </a:defRPr>
             </a:pPr>
             <a:r>
-              <a:t>• Project Manager: Frank Ellingsen</a:t>
+              <a:t>• Focus: Drawings approved, welding &amp; assembly ongoing</a:t>
             </a:r>
           </a:p>
         </p:txBody>
@@ -4256,7 +5893,7 @@
               </a:defRPr>
             </a:pPr>
             <a:r>
-              <a:t>7. PRJ-006 Composite Cargo Hatch</a:t>
+              <a:t>6. PRJ-005 Logistics Pontoon</a:t>
             </a:r>
           </a:p>
         </p:txBody>
@@ -4269,8 +5906,8 @@
         </p:nvSpPr>
         <p:spPr>
           <a:xfrm>
-            <a:off x="685800" y="1828800"/>
-            <a:ext cx="10817352" cy="4114800"/>
+            <a:off x="8686800" y="594360"/>
+            <a:ext cx="2743200" cy="731520"/>
           </a:xfrm>
           <a:prstGeom prst="rect">
             <a:avLst/>
@@ -4278,6 +5915,42 @@
           <a:noFill/>
         </p:spPr>
         <p:txBody>
+          <a:bodyPr wrap="none">
+            <a:spAutoFit/>
+          </a:bodyPr>
+          <a:lstStyle/>
+          <a:p>
+            <a:pPr>
+              <a:defRPr sz="2000" b="1">
+                <a:solidFill>
+                  <a:srgbClr val="2ECC71"/>
+                </a:solidFill>
+                <a:latin typeface="Inter"/>
+              </a:defRPr>
+            </a:pPr>
+            <a:r>
+              <a:t>🟢 ON TRACK</a:t>
+            </a:r>
+          </a:p>
+        </p:txBody>
+      </p:sp>
+      <p:sp>
+        <p:nvSpPr>
+          <p:cNvPr id="4" name="TextBox 3"/>
+          <p:cNvSpPr txBox="1"/>
+          <p:nvPr/>
+        </p:nvSpPr>
+        <p:spPr>
+          <a:xfrm>
+            <a:off x="685800" y="1828800"/>
+            <a:ext cx="10817352" cy="4114800"/>
+          </a:xfrm>
+          <a:prstGeom prst="rect">
+            <a:avLst/>
+          </a:prstGeom>
+          <a:noFill/>
+        </p:spPr>
+        <p:txBody>
           <a:bodyPr wrap="square">
             <a:spAutoFit/>
           </a:bodyPr>
@@ -4289,13 +5962,13 @@
               </a:spcAft>
               <a:defRPr sz="3000">
                 <a:solidFill>
-                  <a:srgbClr val="555555"/>
+                  <a:srgbClr val="2ECC71"/>
                 </a:solidFill>
                 <a:latin typeface="Inter"/>
               </a:defRPr>
             </a:pPr>
             <a:r>
-              <a:t>• Status: Completed (100% progress)</a:t>
+              <a:t>• Status: Active (90% progress) | 🟢 GREEN</a:t>
             </a:r>
           </a:p>
           <a:p>
@@ -4311,7 +5984,7 @@
               </a:defRPr>
             </a:pPr>
             <a:r>
-              <a:t>• Baseline: 600,000 USD | Spent: 586,500 USD</a:t>
+              <a:t>• Baseline: 1.0M USD | Spent: 927K USD</a:t>
             </a:r>
           </a:p>
           <a:p>
@@ -4327,7 +6000,7 @@
               </a:defRPr>
             </a:pPr>
             <a:r>
-              <a:t>• CPI: 1.02 (Under budget success)</a:t>
+              <a:t>• CPI: 0.97 (In good financial standing)</a:t>
             </a:r>
           </a:p>
           <a:p>
@@ -4343,7 +6016,7 @@
               </a:defRPr>
             </a:pPr>
             <a:r>
-              <a:t>• Deliverables: Molding &amp; testing fully verified</a:t>
+              <a:t>• Project Manager: Frank Ellingsen</a:t>
             </a:r>
           </a:p>
         </p:txBody>
@@ -4397,7 +6070,7 @@
               </a:defRPr>
             </a:pPr>
             <a:r>
-              <a:t>8. Key Portfolio Risks &amp; RAID Log</a:t>
+              <a:t>7. PRJ-006 Cargo Hatch</a:t>
             </a:r>
           </a:p>
         </p:txBody>
@@ -4410,8 +6083,8 @@
         </p:nvSpPr>
         <p:spPr>
           <a:xfrm>
-            <a:off x="685800" y="1828800"/>
-            <a:ext cx="10817352" cy="4114800"/>
+            <a:off x="8686800" y="594360"/>
+            <a:ext cx="2743200" cy="731520"/>
           </a:xfrm>
           <a:prstGeom prst="rect">
             <a:avLst/>
@@ -4419,6 +6092,42 @@
           <a:noFill/>
         </p:spPr>
         <p:txBody>
+          <a:bodyPr wrap="none">
+            <a:spAutoFit/>
+          </a:bodyPr>
+          <a:lstStyle/>
+          <a:p>
+            <a:pPr>
+              <a:defRPr sz="2000" b="1">
+                <a:solidFill>
+                  <a:srgbClr val="2ECC71"/>
+                </a:solidFill>
+                <a:latin typeface="Inter"/>
+              </a:defRPr>
+            </a:pPr>
+            <a:r>
+              <a:t>🟢 ON TRACK</a:t>
+            </a:r>
+          </a:p>
+        </p:txBody>
+      </p:sp>
+      <p:sp>
+        <p:nvSpPr>
+          <p:cNvPr id="4" name="TextBox 3"/>
+          <p:cNvSpPr txBox="1"/>
+          <p:nvPr/>
+        </p:nvSpPr>
+        <p:spPr>
+          <a:xfrm>
+            <a:off x="685800" y="1828800"/>
+            <a:ext cx="10817352" cy="4114800"/>
+          </a:xfrm>
+          <a:prstGeom prst="rect">
+            <a:avLst/>
+          </a:prstGeom>
+          <a:noFill/>
+        </p:spPr>
+        <p:txBody>
           <a:bodyPr wrap="square">
             <a:spAutoFit/>
           </a:bodyPr>
@@ -4430,13 +6139,13 @@
               </a:spcAft>
               <a:defRPr sz="3000">
                 <a:solidFill>
-                  <a:srgbClr val="555555"/>
+                  <a:srgbClr val="2ECC71"/>
                 </a:solidFill>
                 <a:latin typeface="Inter"/>
               </a:defRPr>
             </a:pPr>
             <a:r>
-              <a:t>• Risk: Carbon sheet delivery delay from supplier</a:t>
+              <a:t>• Status: Completed (100% progress) | 🟢 GREEN</a:t>
             </a:r>
           </a:p>
           <a:p>
@@ -4452,7 +6161,7 @@
               </a:defRPr>
             </a:pPr>
             <a:r>
-              <a:t>• Issue: Welder overtime limits exceeded in fabrication</a:t>
+              <a:t>• Baseline: 600,000 USD | Spent: 586,500 USD</a:t>
             </a:r>
           </a:p>
           <a:p>
@@ -4468,7 +6177,7 @@
               </a:defRPr>
             </a:pPr>
             <a:r>
-              <a:t>• Dependency: Sea trials depend on DNV class approval</a:t>
+              <a:t>• CPI: 1.02 (Under budget success)</a:t>
             </a:r>
           </a:p>
           <a:p>
@@ -4484,7 +6193,7 @@
               </a:defRPr>
             </a:pPr>
             <a:r>
-              <a:t>• Mitigation: Allocate junior welders to assist</a:t>
+              <a:t>• Deliverables: Molding &amp; testing fully verified</a:t>
             </a:r>
           </a:p>
         </p:txBody>

</xml_diff>